<commit_message>
fix(agent): align strands bedrock parameters and limits, define domain sla tool, add backend gold SLA cost policy check, and clean up strands_agent dead code
</commit_message>
<xml_diff>
--- a/docs/assets/demo/ClauseRunner_Demo_Video_Deck.pptx
+++ b/docs/assets/demo/ClauseRunner_Demo_Video_Deck.pptx
@@ -4,6 +4,9 @@
   <p:sldMasterIdLst>
     <p:sldMasterId id="2147483648" r:id="rId1"/>
   </p:sldMasterIdLst>
+  <p:notesMasterIdLst>
+    <p:notesMasterId r:id="rId9"/>
+  </p:notesMasterIdLst>
   <p:sldIdLst>
     <p:sldId id="256" r:id="rId2"/>
     <p:sldId id="257" r:id="rId3"/>
@@ -13,9 +16,6 @@
     <p:sldId id="261" r:id="rId7"/>
     <p:sldId id="262" r:id="rId8"/>
   </p:sldIdLst>
-  <p:notesMasterIdLst>
-    <p:notesMasterId r:id="rId9"/>
-  </p:notesMasterIdLst>
   <p:sldSz cx="12192000" cy="6858000"/>
   <p:notesSz cx="6858000" cy="12192000"/>
   <p:defaultTextStyle>
@@ -110,6 +110,11 @@
       </a:defRPr>
     </a:lvl9pPr>
   </p:defaultTextStyle>
+  <p:extLst>
+    <p:ext uri="{EFAFB233-063F-42B5-8137-9DF3F51BA10A}">
+      <p15:sldGuideLst xmlns:p15="http://schemas.microsoft.com/office/powerpoint/2012/main"/>
+    </p:ext>
+  </p:extLst>
 </p:presentation>
 </file>
 
@@ -135,234 +140,10 @@
           <a:chExt cx="0" cy="0"/>
         </a:xfrm>
       </p:grpSpPr>
-      <p:sp>
-        <p:nvSpPr>
-          <p:cNvPr id="2" name="Header Placeholder 1"/>
-          <p:cNvSpPr>
-            <a:spLocks noGrp="1"/>
-          </p:cNvSpPr>
-          <p:nvPr>
-            <p:ph type="hdr" sz="quarter"/>
-          </p:nvPr>
-        </p:nvSpPr>
-        <p:spPr>
-          <a:xfrm>
-            <a:off x="0" y="0"/>
-            <a:ext cx="2971800" cy="458788"/>
-          </a:xfrm>
-          <a:prstGeom prst="rect">
-            <a:avLst/>
-          </a:prstGeom>
-        </p:spPr>
-        <p:txBody>
-          <a:bodyPr vert="horz" lIns="91440" tIns="45720" rIns="91440" bIns="45720" rtlCol="0"/>
-          <a:lstStyle>
-            <a:lvl1pPr algn="l">
-              <a:defRPr sz="1200"/>
-            </a:lvl1pPr>
-          </a:lstStyle>
-          <a:p>
-            <a:endParaRPr lang="en-US"/>
-          </a:p>
-        </p:txBody>
-      </p:sp>
-      <p:sp>
-        <p:nvSpPr>
-          <p:cNvPr id="3" name="Date Placeholder 2"/>
-          <p:cNvSpPr>
-            <a:spLocks noGrp="1"/>
-          </p:cNvSpPr>
-          <p:nvPr>
-            <p:ph type="dt" idx="1"/>
-          </p:nvPr>
-        </p:nvSpPr>
-        <p:spPr>
-          <a:xfrm>
-            <a:off x="3884613" y="0"/>
-            <a:ext cx="2971800" cy="458788"/>
-          </a:xfrm>
-          <a:prstGeom prst="rect">
-            <a:avLst/>
-          </a:prstGeom>
-        </p:spPr>
-        <p:txBody>
-          <a:bodyPr vert="horz" lIns="91440" tIns="45720" rIns="91440" bIns="45720" rtlCol="0"/>
-          <a:lstStyle>
-            <a:lvl1pPr algn="r">
-              <a:defRPr sz="1200"/>
-            </a:lvl1pPr>
-          </a:lstStyle>
-          <a:p>
-            <a:fld id="{5282F153-3F37-0F45-9E97-73ACFA13230C}" type="datetimeFigureOut">
-              <a:rPr lang="en-US"/>
-              <a:t>7/23/19</a:t>
-            </a:fld>
-            <a:endParaRPr lang="en-US"/>
-          </a:p>
-        </p:txBody>
-      </p:sp>
-      <p:sp>
-        <p:nvSpPr>
-          <p:cNvPr id="4" name="Slide Image Placeholder 3"/>
-          <p:cNvSpPr>
-            <a:spLocks noGrp="1" noRot="1" noChangeAspect="1"/>
-          </p:cNvSpPr>
-          <p:nvPr>
-            <p:ph type="sldImg" idx="2"/>
-          </p:nvPr>
-        </p:nvSpPr>
-        <p:spPr>
-          <a:xfrm>
-            <a:off x="685800" y="1143000"/>
-            <a:ext cx="5486400" cy="3086100"/>
-          </a:xfrm>
-          <a:prstGeom prst="rect">
-            <a:avLst/>
-          </a:prstGeom>
-          <a:noFill/>
-          <a:ln w="12700">
-            <a:solidFill>
-              <a:prstClr val="black"/>
-            </a:solidFill>
-          </a:ln>
-        </p:spPr>
-        <p:txBody>
-          <a:bodyPr vert="horz" lIns="91440" tIns="45720" rIns="91440" bIns="45720" rtlCol="0" anchor="ctr"/>
-          <a:lstStyle/>
-          <a:p>
-            <a:endParaRPr lang="en-US"/>
-          </a:p>
-        </p:txBody>
-      </p:sp>
-      <p:sp>
-        <p:nvSpPr>
-          <p:cNvPr id="5" name="Notes Placeholder 4"/>
-          <p:cNvSpPr>
-            <a:spLocks noGrp="1"/>
-          </p:cNvSpPr>
-          <p:nvPr>
-            <p:ph type="body" sz="quarter" idx="3"/>
-          </p:nvPr>
-        </p:nvSpPr>
-        <p:spPr>
-          <a:xfrm>
-            <a:off x="685800" y="4400550"/>
-            <a:ext cx="5486400" cy="3600450"/>
-          </a:xfrm>
-          <a:prstGeom prst="rect">
-            <a:avLst/>
-          </a:prstGeom>
-        </p:spPr>
-        <p:txBody>
-          <a:bodyPr vert="horz" lIns="91440" tIns="45720" rIns="91440" bIns="45720" rtlCol="0"/>
-          <a:lstStyle/>
-          <a:p>
-            <a:pPr lvl="0"/>
-            <a:r>
-              <a:rPr lang="en-US"/>
-              <a:t>Click to edit Master text styles</a:t>
-            </a:r>
-          </a:p>
-          <a:p>
-            <a:pPr lvl="1"/>
-            <a:r>
-              <a:rPr lang="en-US"/>
-              <a:t>Second level</a:t>
-            </a:r>
-          </a:p>
-          <a:p>
-            <a:pPr lvl="2"/>
-            <a:r>
-              <a:rPr lang="en-US"/>
-              <a:t>Third level</a:t>
-            </a:r>
-          </a:p>
-          <a:p>
-            <a:pPr lvl="3"/>
-            <a:r>
-              <a:rPr lang="en-US"/>
-              <a:t>Fourth level</a:t>
-            </a:r>
-          </a:p>
-          <a:p>
-            <a:pPr lvl="4"/>
-            <a:r>
-              <a:rPr lang="en-US"/>
-              <a:t>Fifth level</a:t>
-            </a:r>
-          </a:p>
-        </p:txBody>
-      </p:sp>
-      <p:sp>
-        <p:nvSpPr>
-          <p:cNvPr id="6" name="Footer Placeholder 5"/>
-          <p:cNvSpPr>
-            <a:spLocks noGrp="1"/>
-          </p:cNvSpPr>
-          <p:nvPr>
-            <p:ph type="ftr" sz="quarter" idx="4"/>
-          </p:nvPr>
-        </p:nvSpPr>
-        <p:spPr>
-          <a:xfrm>
-            <a:off x="0" y="8685213"/>
-            <a:ext cx="2971800" cy="458787"/>
-          </a:xfrm>
-          <a:prstGeom prst="rect">
-            <a:avLst/>
-          </a:prstGeom>
-        </p:spPr>
-        <p:txBody>
-          <a:bodyPr vert="horz" lIns="91440" tIns="45720" rIns="91440" bIns="45720" rtlCol="0" anchor="b"/>
-          <a:lstStyle>
-            <a:lvl1pPr algn="l">
-              <a:defRPr sz="1200"/>
-            </a:lvl1pPr>
-          </a:lstStyle>
-          <a:p>
-            <a:endParaRPr lang="en-US"/>
-          </a:p>
-        </p:txBody>
-      </p:sp>
-      <p:sp>
-        <p:nvSpPr>
-          <p:cNvPr id="7" name="Slide Number Placeholder 6"/>
-          <p:cNvSpPr>
-            <a:spLocks noGrp="1"/>
-          </p:cNvSpPr>
-          <p:nvPr>
-            <p:ph type="sldNum" sz="quarter" idx="5"/>
-          </p:nvPr>
-        </p:nvSpPr>
-        <p:spPr>
-          <a:xfrm>
-            <a:off x="3884613" y="8685213"/>
-            <a:ext cx="2971800" cy="458787"/>
-          </a:xfrm>
-          <a:prstGeom prst="rect">
-            <a:avLst/>
-          </a:prstGeom>
-        </p:spPr>
-        <p:txBody>
-          <a:bodyPr vert="horz" lIns="91440" tIns="45720" rIns="91440" bIns="45720" rtlCol="0" anchor="b"/>
-          <a:lstStyle>
-            <a:lvl1pPr algn="r">
-              <a:defRPr sz="1200"/>
-            </a:lvl1pPr>
-          </a:lstStyle>
-          <a:p>
-            <a:fld id="{CE5E9CC1-C706-0F49-92D6-E571CC5EEA8F}" type="slidenum">
-              <a:rPr lang="en-US"/>
-              <a:t>‹#›</a:t>
-            </a:fld>
-            <a:endParaRPr lang="en-US"/>
-          </a:p>
-        </p:txBody>
-      </p:sp>
     </p:spTree>
     <p:extLst>
       <p:ext uri="{BB962C8B-B14F-4D97-AF65-F5344CB8AC3E}">
-        <p14:creationId xmlns:p14="http://schemas.microsoft.com/office/powerpoint/2010/main" val="1024086991"/>
+        <p14:creationId xmlns:p14="http://schemas.microsoft.com/office/powerpoint/2010/main" val="3138560713"/>
       </p:ext>
     </p:extLst>
   </p:cSld>
@@ -506,10 +287,6 @@
           <a:bodyPr/>
           <a:lstStyle/>
           <a:p>
-            <a:r>
-              <a:rPr lang="en-US" dirty="0"/>
-              <a:t/>
-            </a:r>
             <a:endParaRPr lang="en-US" dirty="0"/>
           </a:p>
         </p:txBody>
@@ -594,10 +371,6 @@
           <a:bodyPr/>
           <a:lstStyle/>
           <a:p>
-            <a:r>
-              <a:rPr lang="en-US" dirty="0"/>
-              <a:t/>
-            </a:r>
             <a:endParaRPr lang="en-US" dirty="0"/>
           </a:p>
         </p:txBody>
@@ -682,10 +455,6 @@
           <a:bodyPr/>
           <a:lstStyle/>
           <a:p>
-            <a:r>
-              <a:rPr lang="en-US" dirty="0"/>
-              <a:t/>
-            </a:r>
             <a:endParaRPr lang="en-US" dirty="0"/>
           </a:p>
         </p:txBody>
@@ -770,10 +539,6 @@
           <a:bodyPr/>
           <a:lstStyle/>
           <a:p>
-            <a:r>
-              <a:rPr lang="en-US" dirty="0"/>
-              <a:t/>
-            </a:r>
             <a:endParaRPr lang="en-US" dirty="0"/>
           </a:p>
         </p:txBody>
@@ -858,10 +623,6 @@
           <a:bodyPr/>
           <a:lstStyle/>
           <a:p>
-            <a:r>
-              <a:rPr lang="en-US" dirty="0"/>
-              <a:t/>
-            </a:r>
             <a:endParaRPr lang="en-US" dirty="0"/>
           </a:p>
         </p:txBody>
@@ -946,10 +707,6 @@
           <a:bodyPr/>
           <a:lstStyle/>
           <a:p>
-            <a:r>
-              <a:rPr lang="en-US" dirty="0"/>
-              <a:t/>
-            </a:r>
             <a:endParaRPr lang="en-US" dirty="0"/>
           </a:p>
         </p:txBody>
@@ -1034,10 +791,6 @@
           <a:bodyPr/>
           <a:lstStyle/>
           <a:p>
-            <a:r>
-              <a:rPr lang="en-US" dirty="0"/>
-              <a:t/>
-            </a:r>
             <a:endParaRPr lang="en-US" dirty="0"/>
           </a:p>
         </p:txBody>
@@ -1116,6 +869,7 @@
         <a:solidFill>
           <a:srgbClr val="F7F9FC"/>
         </a:solidFill>
+        <a:effectLst/>
       </p:bgPr>
     </p:bg>
     <p:spTree>
@@ -1176,7 +930,7 @@
           <a:bodyPr wrap="square" lIns="0" tIns="0" rIns="0" bIns="0" rtlCol="0" anchor="ctr"/>
           <a:lstStyle/>
           <a:p>
-            <a:pPr indent="0" marL="0">
+            <a:pPr marL="0" indent="0">
               <a:buNone/>
             </a:pPr>
             <a:r>
@@ -1214,7 +968,7 @@
           </a:prstGeom>
           <a:extLst>
             <a:ext uri="{C572A759-6A51-4108-AA02-DFA0A04FC94B}">
-              <ma14:wrappingTextBoxFlag xmlns:ma14="http://schemas.microsoft.com/office/mac/drawingml/2011/main" val="0"/>
+              <ma14:wrappingTextBoxFlag xmlns:ma14="http://schemas.microsoft.com/office/mac/drawingml/2011/main" xmlns="" val="0"/>
             </a:ext>
           </a:extLst>
         </p:spPr>
@@ -1235,8 +989,8 @@
           <a:p>
             <a:pPr algn="l"/>
             <a:fld id="{F7021451-1387-4CA6-816F-3879F97B5CBC}" type="slidenum">
-              <a:rPr b="0" lang="en-US"/>
-              <a:t>1002</a:t>
+              <a:rPr lang="en-US" b="0"/>
+              <a:t>‹#›</a:t>
             </a:fld>
             <a:endParaRPr lang="en-US"/>
           </a:p>
@@ -1258,6 +1012,7 @@
         <a:solidFill>
           <a:srgbClr val="0B1426"/>
         </a:solidFill>
+        <a:effectLst/>
       </p:bgPr>
     </p:bg>
     <p:spTree>
@@ -1295,7 +1050,7 @@
           <a:bodyPr wrap="square" lIns="0" tIns="0" rIns="0" bIns="0" rtlCol="0" anchor="ctr"/>
           <a:lstStyle/>
           <a:p>
-            <a:pPr indent="0" marL="0">
+            <a:pPr marL="0" indent="0">
               <a:buNone/>
             </a:pPr>
             <a:r>
@@ -1333,7 +1088,7 @@
           </a:prstGeom>
           <a:extLst>
             <a:ext uri="{C572A759-6A51-4108-AA02-DFA0A04FC94B}">
-              <ma14:wrappingTextBoxFlag xmlns:ma14="http://schemas.microsoft.com/office/mac/drawingml/2011/main" val="0"/>
+              <ma14:wrappingTextBoxFlag xmlns:ma14="http://schemas.microsoft.com/office/mac/drawingml/2011/main" xmlns="" val="0"/>
             </a:ext>
           </a:extLst>
         </p:spPr>
@@ -1354,8 +1109,8 @@
           <a:p>
             <a:pPr algn="l"/>
             <a:fld id="{F7021451-1387-4CA6-816F-3879F97B5CBC}" type="slidenum">
-              <a:rPr b="0" lang="en-US"/>
-              <a:t>1003</a:t>
+              <a:rPr lang="en-US" b="0"/>
+              <a:t>‹#›</a:t>
             </a:fld>
             <a:endParaRPr lang="en-US"/>
           </a:p>
@@ -1372,6 +1127,11 @@
 <file path=ppt/slideMasters/slideMaster1.xml><?xml version="1.0" encoding="utf-8"?>
 <p:sldMaster xmlns:a="http://schemas.openxmlformats.org/drawingml/2006/main" xmlns:r="http://schemas.openxmlformats.org/officeDocument/2006/relationships" xmlns:p="http://schemas.openxmlformats.org/presentationml/2006/main">
   <p:cSld>
+    <p:bg>
+      <p:bgRef idx="1001">
+        <a:schemeClr val="bg1"/>
+      </p:bgRef>
+    </p:bg>
     <p:spTree>
       <p:nvGrpSpPr>
         <p:cNvPr id="1" name=""/>
@@ -1406,7 +1166,7 @@
           </a:prstGeom>
           <a:extLst>
             <a:ext uri="{C572A759-6A51-4108-AA02-DFA0A04FC94B}">
-              <ma14:wrappingTextBoxFlag xmlns:ma14="http://schemas.microsoft.com/office/mac/drawingml/2011/main" val="0"/>
+              <ma14:wrappingTextBoxFlag xmlns:ma14="http://schemas.microsoft.com/office/mac/drawingml/2011/main" xmlns="" val="0"/>
             </a:ext>
           </a:extLst>
         </p:spPr>
@@ -1427,8 +1187,8 @@
           <a:p>
             <a:pPr algn="l"/>
             <a:fld id="{F7021451-1387-4CA6-816F-3879F97B5CBC}" type="slidenum">
-              <a:rPr b="0" lang="en-US"/>
-              <a:t>null</a:t>
+              <a:rPr lang="en-US" b="0"/>
+              <a:t>‹#›</a:t>
             </a:fld>
             <a:endParaRPr lang="en-US"/>
           </a:p>
@@ -1737,6 +1497,13 @@
             <a:prstDash val="solid"/>
           </a:ln>
         </p:spPr>
+        <p:txBody>
+          <a:bodyPr/>
+          <a:lstStyle/>
+          <a:p>
+            <a:endParaRPr lang="en-IN"/>
+          </a:p>
+        </p:txBody>
       </p:sp>
       <p:sp>
         <p:nvSpPr>
@@ -1759,7 +1526,7 @@
           <a:bodyPr wrap="square" lIns="0" tIns="0" rIns="0" bIns="0" rtlCol="0" anchor="ctr"/>
           <a:lstStyle/>
           <a:p>
-            <a:pPr algn="ctr" indent="0" marL="0">
+            <a:pPr marL="0" indent="0" algn="ctr">
               <a:buNone/>
             </a:pPr>
             <a:r>
@@ -1795,7 +1562,7 @@
           <a:bodyPr wrap="square" lIns="0" tIns="0" rIns="0" bIns="0" rtlCol="0" anchor="ctr"/>
           <a:lstStyle/>
           <a:p>
-            <a:pPr indent="0" marL="0">
+            <a:pPr marL="0" indent="0">
               <a:buNone/>
             </a:pPr>
             <a:r>
@@ -1836,7 +1603,7 @@
           </a:bodyPr>
           <a:lstStyle/>
           <a:p>
-            <a:pPr indent="0" marL="0">
+            <a:pPr marL="0" indent="0">
               <a:buNone/>
             </a:pPr>
             <a:r>
@@ -1850,7 +1617,7 @@
             <a:endParaRPr lang="en-US" sz="1800" dirty="0"/>
           </a:p>
           <a:p>
-            <a:pPr indent="0" marL="0">
+            <a:pPr marL="0" indent="0">
               <a:buNone/>
             </a:pPr>
             <a:r>
@@ -1886,7 +1653,7 @@
           <a:bodyPr wrap="square" lIns="0" tIns="0" rIns="0" bIns="0" rtlCol="0" anchor="ctr"/>
           <a:lstStyle/>
           <a:p>
-            <a:pPr indent="0" marL="0">
+            <a:pPr marL="0" indent="0">
               <a:buNone/>
             </a:pPr>
             <a:r>
@@ -1923,6 +1690,13 @@
             <a:prstDash val="solid"/>
           </a:ln>
         </p:spPr>
+        <p:txBody>
+          <a:bodyPr/>
+          <a:lstStyle/>
+          <a:p>
+            <a:endParaRPr lang="en-IN"/>
+          </a:p>
+        </p:txBody>
       </p:sp>
       <p:sp>
         <p:nvSpPr>
@@ -1947,7 +1721,7 @@
           </a:bodyPr>
           <a:lstStyle/>
           <a:p>
-            <a:pPr indent="0" marL="0">
+            <a:pPr marL="0" indent="0">
               <a:buNone/>
             </a:pPr>
             <a:r>
@@ -1986,24 +1760,31 @@
             <a:prstDash val="solid"/>
           </a:ln>
           <a:effectLst>
-            <a:outerShdw sx="100000" sy="100000" kx="0" ky="0" algn="bl" rotWithShape="0" blurRad="25400" dist="50800" dir="2700000">
+            <a:outerShdw blurRad="25400" dist="50800" dir="2700000" algn="bl" rotWithShape="0">
               <a:srgbClr val="000000">
                 <a:alpha val="18000"/>
               </a:srgbClr>
             </a:outerShdw>
           </a:effectLst>
         </p:spPr>
+        <p:txBody>
+          <a:bodyPr/>
+          <a:lstStyle/>
+          <a:p>
+            <a:endParaRPr lang="en-IN"/>
+          </a:p>
+        </p:txBody>
       </p:sp>
       <p:pic>
         <p:nvPicPr>
-          <p:cNvPr id="10" name="Image 0" descr="/mnt/data/01_ClauseRunner_Dashboard.png">    </p:cNvPr>
+          <p:cNvPr id="10" name="Image 0" descr="/mnt/data/01_ClauseRunner_Dashboard.png"/>
           <p:cNvPicPr>
             <a:picLocks noChangeAspect="1"/>
           </p:cNvPicPr>
           <p:nvPr/>
         </p:nvPicPr>
         <p:blipFill>
-          <a:blip r:embed="rId1"/>
+          <a:blip r:embed="rId3"/>
           <a:stretch>
             <a:fillRect/>
           </a:stretch>
@@ -2026,7 +1807,7 @@
         </p:nvSpPr>
         <p:spPr>
           <a:xfrm>
-            <a:off x="5440680" y="6007608"/>
+            <a:off x="7004304" y="6216427"/>
             <a:ext cx="2926080" cy="219456"/>
           </a:xfrm>
           <a:prstGeom prst="rect">
@@ -2039,7 +1820,7 @@
           <a:bodyPr wrap="square" lIns="0" tIns="0" rIns="0" bIns="0" rtlCol="0" anchor="ctr"/>
           <a:lstStyle/>
           <a:p>
-            <a:pPr indent="0" marL="0">
+            <a:pPr marL="0" indent="0" algn="ctr">
               <a:buNone/>
             </a:pPr>
             <a:r>
@@ -2074,7 +1855,7 @@
           </a:prstGeom>
           <a:extLst>
             <a:ext uri="{C572A759-6A51-4108-AA02-DFA0A04FC94B}">
-              <ma14:wrappingTextBoxFlag xmlns:ma14="http://schemas.microsoft.com/office/mac/drawingml/2011/main" val="0"/>
+              <ma14:wrappingTextBoxFlag xmlns:ma14="http://schemas.microsoft.com/office/mac/drawingml/2011/main" xmlns="" val="0"/>
             </a:ext>
           </a:extLst>
         </p:spPr>
@@ -2095,7 +1876,7 @@
           <a:p>
             <a:pPr algn="l"/>
             <a:fld id="{F7021451-1387-4CA6-816F-3879F97B5CBC}" type="slidenum">
-              <a:rPr b="0" lang="en-US"/>
+              <a:rPr lang="en-US" b="0"/>
               <a:t>1</a:t>
             </a:fld>
             <a:endParaRPr lang="en-US"/>
@@ -2150,7 +1931,7 @@
           </a:bodyPr>
           <a:lstStyle/>
           <a:p>
-            <a:pPr indent="0" marL="0">
+            <a:pPr marL="0" indent="0">
               <a:buNone/>
             </a:pPr>
             <a:r>
@@ -2191,7 +1972,7 @@
           </a:bodyPr>
           <a:lstStyle/>
           <a:p>
-            <a:pPr indent="0" marL="0">
+            <a:pPr marL="0" indent="0">
               <a:buNone/>
             </a:pPr>
             <a:r>
@@ -2232,7 +2013,7 @@
           </a:bodyPr>
           <a:lstStyle/>
           <a:p>
-            <a:pPr indent="0" marL="0">
+            <a:pPr marL="0" indent="0">
               <a:buNone/>
             </a:pPr>
             <a:r>
@@ -2270,7 +2051,7 @@
           </a:bodyPr>
           <a:lstStyle/>
           <a:p>
-            <a:pPr indent="0" marL="0">
+            <a:pPr marL="0" indent="0">
               <a:buNone/>
             </a:pPr>
             <a:r>
@@ -2311,13 +2092,20 @@
             <a:prstDash val="solid"/>
           </a:ln>
           <a:effectLst>
-            <a:outerShdw sx="100000" sy="100000" kx="0" ky="0" algn="bl" rotWithShape="0" blurRad="19050" dist="50800" dir="2700000">
+            <a:outerShdw blurRad="19050" dist="50800" dir="2700000" algn="bl" rotWithShape="0">
               <a:srgbClr val="B8C5D6">
                 <a:alpha val="16000"/>
               </a:srgbClr>
             </a:outerShdw>
           </a:effectLst>
         </p:spPr>
+        <p:txBody>
+          <a:bodyPr/>
+          <a:lstStyle/>
+          <a:p>
+            <a:endParaRPr lang="en-IN"/>
+          </a:p>
+        </p:txBody>
       </p:sp>
       <p:sp>
         <p:nvSpPr>
@@ -2343,6 +2131,13 @@
             <a:prstDash val="solid"/>
           </a:ln>
         </p:spPr>
+        <p:txBody>
+          <a:bodyPr/>
+          <a:lstStyle/>
+          <a:p>
+            <a:endParaRPr lang="en-IN"/>
+          </a:p>
+        </p:txBody>
       </p:sp>
       <p:sp>
         <p:nvSpPr>
@@ -2367,7 +2162,7 @@
           </a:bodyPr>
           <a:lstStyle/>
           <a:p>
-            <a:pPr indent="0" marL="0">
+            <a:pPr marL="0" indent="0">
               <a:buNone/>
             </a:pPr>
             <a:r>
@@ -2405,7 +2200,7 @@
           </a:bodyPr>
           <a:lstStyle/>
           <a:p>
-            <a:pPr indent="0" marL="0">
+            <a:pPr marL="0" indent="0">
               <a:buNone/>
             </a:pPr>
             <a:r>
@@ -2446,13 +2241,20 @@
             <a:prstDash val="solid"/>
           </a:ln>
           <a:effectLst>
-            <a:outerShdw sx="100000" sy="100000" kx="0" ky="0" algn="bl" rotWithShape="0" blurRad="19050" dist="50800" dir="2700000">
+            <a:outerShdw blurRad="19050" dist="50800" dir="2700000" algn="bl" rotWithShape="0">
               <a:srgbClr val="B8C5D6">
                 <a:alpha val="16000"/>
               </a:srgbClr>
             </a:outerShdw>
           </a:effectLst>
         </p:spPr>
+        <p:txBody>
+          <a:bodyPr/>
+          <a:lstStyle/>
+          <a:p>
+            <a:endParaRPr lang="en-IN"/>
+          </a:p>
+        </p:txBody>
       </p:sp>
       <p:sp>
         <p:nvSpPr>
@@ -2478,6 +2280,13 @@
             <a:prstDash val="solid"/>
           </a:ln>
         </p:spPr>
+        <p:txBody>
+          <a:bodyPr/>
+          <a:lstStyle/>
+          <a:p>
+            <a:endParaRPr lang="en-IN"/>
+          </a:p>
+        </p:txBody>
       </p:sp>
       <p:sp>
         <p:nvSpPr>
@@ -2502,7 +2311,7 @@
           </a:bodyPr>
           <a:lstStyle/>
           <a:p>
-            <a:pPr indent="0" marL="0">
+            <a:pPr marL="0" indent="0">
               <a:buNone/>
             </a:pPr>
             <a:r>
@@ -2540,7 +2349,7 @@
           </a:bodyPr>
           <a:lstStyle/>
           <a:p>
-            <a:pPr indent="0" marL="0">
+            <a:pPr marL="0" indent="0">
               <a:buNone/>
             </a:pPr>
             <a:r>
@@ -2581,13 +2390,20 @@
             <a:prstDash val="solid"/>
           </a:ln>
           <a:effectLst>
-            <a:outerShdw sx="100000" sy="100000" kx="0" ky="0" algn="bl" rotWithShape="0" blurRad="19050" dist="50800" dir="2700000">
+            <a:outerShdw blurRad="19050" dist="50800" dir="2700000" algn="bl" rotWithShape="0">
               <a:srgbClr val="B8C5D6">
                 <a:alpha val="16000"/>
               </a:srgbClr>
             </a:outerShdw>
           </a:effectLst>
         </p:spPr>
+        <p:txBody>
+          <a:bodyPr/>
+          <a:lstStyle/>
+          <a:p>
+            <a:endParaRPr lang="en-IN"/>
+          </a:p>
+        </p:txBody>
       </p:sp>
       <p:sp>
         <p:nvSpPr>
@@ -2613,6 +2429,13 @@
             <a:prstDash val="solid"/>
           </a:ln>
         </p:spPr>
+        <p:txBody>
+          <a:bodyPr/>
+          <a:lstStyle/>
+          <a:p>
+            <a:endParaRPr lang="en-IN"/>
+          </a:p>
+        </p:txBody>
       </p:sp>
       <p:sp>
         <p:nvSpPr>
@@ -2637,7 +2460,7 @@
           </a:bodyPr>
           <a:lstStyle/>
           <a:p>
-            <a:pPr indent="0" marL="0">
+            <a:pPr marL="0" indent="0">
               <a:buNone/>
             </a:pPr>
             <a:r>
@@ -2675,7 +2498,7 @@
           </a:bodyPr>
           <a:lstStyle/>
           <a:p>
-            <a:pPr indent="0" marL="0">
+            <a:pPr marL="0" indent="0">
               <a:buNone/>
             </a:pPr>
             <a:r>
@@ -2716,13 +2539,20 @@
             <a:prstDash val="solid"/>
           </a:ln>
           <a:effectLst>
-            <a:outerShdw sx="100000" sy="100000" kx="0" ky="0" algn="bl" rotWithShape="0" blurRad="19050" dist="50800" dir="2700000">
+            <a:outerShdw blurRad="19050" dist="50800" dir="2700000" algn="bl" rotWithShape="0">
               <a:srgbClr val="B8C5D6">
                 <a:alpha val="16000"/>
               </a:srgbClr>
             </a:outerShdw>
           </a:effectLst>
         </p:spPr>
+        <p:txBody>
+          <a:bodyPr/>
+          <a:lstStyle/>
+          <a:p>
+            <a:endParaRPr lang="en-IN"/>
+          </a:p>
+        </p:txBody>
       </p:sp>
       <p:sp>
         <p:nvSpPr>
@@ -2748,6 +2578,13 @@
             <a:prstDash val="solid"/>
           </a:ln>
         </p:spPr>
+        <p:txBody>
+          <a:bodyPr/>
+          <a:lstStyle/>
+          <a:p>
+            <a:endParaRPr lang="en-IN"/>
+          </a:p>
+        </p:txBody>
       </p:sp>
       <p:sp>
         <p:nvSpPr>
@@ -2772,7 +2609,7 @@
           </a:bodyPr>
           <a:lstStyle/>
           <a:p>
-            <a:pPr indent="0" marL="0">
+            <a:pPr marL="0" indent="0">
               <a:buNone/>
             </a:pPr>
             <a:r>
@@ -2810,7 +2647,7 @@
           </a:bodyPr>
           <a:lstStyle/>
           <a:p>
-            <a:pPr indent="0" marL="0">
+            <a:pPr marL="0" indent="0">
               <a:buNone/>
             </a:pPr>
             <a:r>
@@ -2849,24 +2686,31 @@
             <a:prstDash val="solid"/>
           </a:ln>
           <a:effectLst>
-            <a:outerShdw sx="100000" sy="100000" kx="0" ky="0" algn="bl" rotWithShape="0" blurRad="19050" dist="50800" dir="2700000">
+            <a:outerShdw blurRad="19050" dist="50800" dir="2700000" algn="bl" rotWithShape="0">
               <a:srgbClr val="B8C5D6">
                 <a:alpha val="16000"/>
               </a:srgbClr>
             </a:outerShdw>
           </a:effectLst>
         </p:spPr>
+        <p:txBody>
+          <a:bodyPr/>
+          <a:lstStyle/>
+          <a:p>
+            <a:endParaRPr lang="en-IN"/>
+          </a:p>
+        </p:txBody>
       </p:sp>
       <p:pic>
         <p:nvPicPr>
-          <p:cNvPr id="23" name="Image 0" descr="/mnt/data/03_Human_Approval_Queue.png">    </p:cNvPr>
+          <p:cNvPr id="23" name="Image 0" descr="/mnt/data/03_Human_Approval_Queue.png"/>
           <p:cNvPicPr>
             <a:picLocks noChangeAspect="1"/>
           </p:cNvPicPr>
           <p:nvPr/>
         </p:nvPicPr>
         <p:blipFill>
-          <a:blip r:embed="rId1"/>
+          <a:blip r:embed="rId3"/>
           <a:stretch>
             <a:fillRect/>
           </a:stretch>
@@ -2889,7 +2733,7 @@
         </p:nvSpPr>
         <p:spPr>
           <a:xfrm>
-            <a:off x="6309360" y="5650992"/>
+            <a:off x="6309360" y="5907024"/>
             <a:ext cx="5074920" cy="310896"/>
           </a:xfrm>
           <a:prstGeom prst="rect">
@@ -2902,7 +2746,7 @@
           <a:bodyPr wrap="square" lIns="0" tIns="0" rIns="0" bIns="0" rtlCol="0" anchor="ctr"/>
           <a:lstStyle/>
           <a:p>
-            <a:pPr algn="ctr" indent="0" marL="0">
+            <a:pPr marL="0" indent="0" algn="ctr">
               <a:buNone/>
             </a:pPr>
             <a:r>
@@ -2937,7 +2781,7 @@
           </a:prstGeom>
           <a:extLst>
             <a:ext uri="{C572A759-6A51-4108-AA02-DFA0A04FC94B}">
-              <ma14:wrappingTextBoxFlag xmlns:ma14="http://schemas.microsoft.com/office/mac/drawingml/2011/main" val="0"/>
+              <ma14:wrappingTextBoxFlag xmlns:ma14="http://schemas.microsoft.com/office/mac/drawingml/2011/main" xmlns="" val="0"/>
             </a:ext>
           </a:extLst>
         </p:spPr>
@@ -2958,7 +2802,7 @@
           <a:p>
             <a:pPr algn="l"/>
             <a:fld id="{F7021451-1387-4CA6-816F-3879F97B5CBC}" type="slidenum">
-              <a:rPr b="0" lang="en-US"/>
+              <a:rPr lang="en-US" b="0"/>
               <a:t>2</a:t>
             </a:fld>
             <a:endParaRPr lang="en-US"/>
@@ -3013,7 +2857,7 @@
           </a:bodyPr>
           <a:lstStyle/>
           <a:p>
-            <a:pPr indent="0" marL="0">
+            <a:pPr marL="0" indent="0">
               <a:buNone/>
             </a:pPr>
             <a:r>
@@ -3054,7 +2898,7 @@
           </a:bodyPr>
           <a:lstStyle/>
           <a:p>
-            <a:pPr indent="0" marL="0">
+            <a:pPr marL="0" indent="0">
               <a:buNone/>
             </a:pPr>
             <a:r>
@@ -3096,6 +2940,13 @@
             <a:prstDash val="solid"/>
           </a:ln>
         </p:spPr>
+        <p:txBody>
+          <a:bodyPr/>
+          <a:lstStyle/>
+          <a:p>
+            <a:endParaRPr lang="en-IN"/>
+          </a:p>
+        </p:txBody>
       </p:sp>
       <p:sp>
         <p:nvSpPr>
@@ -3118,7 +2969,7 @@
           <a:bodyPr wrap="square" lIns="0" tIns="0" rIns="0" bIns="0" rtlCol="0" anchor="ctr"/>
           <a:lstStyle/>
           <a:p>
-            <a:pPr algn="ctr" indent="0" marL="0">
+            <a:pPr marL="0" indent="0" algn="ctr">
               <a:buNone/>
             </a:pPr>
             <a:r>
@@ -3157,6 +3008,13 @@
             <a:prstDash val="solid"/>
           </a:ln>
         </p:spPr>
+        <p:txBody>
+          <a:bodyPr/>
+          <a:lstStyle/>
+          <a:p>
+            <a:endParaRPr lang="en-IN"/>
+          </a:p>
+        </p:txBody>
       </p:sp>
       <p:sp>
         <p:nvSpPr>
@@ -3182,6 +3040,13 @@
             <a:prstDash val="solid"/>
           </a:ln>
         </p:spPr>
+        <p:txBody>
+          <a:bodyPr/>
+          <a:lstStyle/>
+          <a:p>
+            <a:endParaRPr lang="en-IN"/>
+          </a:p>
+        </p:txBody>
       </p:sp>
       <p:sp>
         <p:nvSpPr>
@@ -3204,7 +3069,7 @@
           <a:bodyPr wrap="square" lIns="0" tIns="0" rIns="0" bIns="0" rtlCol="0" anchor="ctr"/>
           <a:lstStyle/>
           <a:p>
-            <a:pPr algn="ctr" indent="0" marL="0">
+            <a:pPr marL="0" indent="0" algn="ctr">
               <a:buNone/>
             </a:pPr>
             <a:r>
@@ -3243,6 +3108,13 @@
             <a:prstDash val="solid"/>
           </a:ln>
         </p:spPr>
+        <p:txBody>
+          <a:bodyPr/>
+          <a:lstStyle/>
+          <a:p>
+            <a:endParaRPr lang="en-IN"/>
+          </a:p>
+        </p:txBody>
       </p:sp>
       <p:sp>
         <p:nvSpPr>
@@ -3268,6 +3140,13 @@
             <a:prstDash val="solid"/>
           </a:ln>
         </p:spPr>
+        <p:txBody>
+          <a:bodyPr/>
+          <a:lstStyle/>
+          <a:p>
+            <a:endParaRPr lang="en-IN"/>
+          </a:p>
+        </p:txBody>
       </p:sp>
       <p:sp>
         <p:nvSpPr>
@@ -3290,7 +3169,7 @@
           <a:bodyPr wrap="square" lIns="0" tIns="0" rIns="0" bIns="0" rtlCol="0" anchor="ctr"/>
           <a:lstStyle/>
           <a:p>
-            <a:pPr algn="ctr" indent="0" marL="0">
+            <a:pPr marL="0" indent="0" algn="ctr">
               <a:buNone/>
             </a:pPr>
             <a:r>
@@ -3329,6 +3208,13 @@
             <a:prstDash val="solid"/>
           </a:ln>
         </p:spPr>
+        <p:txBody>
+          <a:bodyPr/>
+          <a:lstStyle/>
+          <a:p>
+            <a:endParaRPr lang="en-IN"/>
+          </a:p>
+        </p:txBody>
       </p:sp>
       <p:sp>
         <p:nvSpPr>
@@ -3354,6 +3240,13 @@
             <a:prstDash val="solid"/>
           </a:ln>
         </p:spPr>
+        <p:txBody>
+          <a:bodyPr/>
+          <a:lstStyle/>
+          <a:p>
+            <a:endParaRPr lang="en-IN"/>
+          </a:p>
+        </p:txBody>
       </p:sp>
       <p:sp>
         <p:nvSpPr>
@@ -3376,7 +3269,7 @@
           <a:bodyPr wrap="square" lIns="0" tIns="0" rIns="0" bIns="0" rtlCol="0" anchor="ctr"/>
           <a:lstStyle/>
           <a:p>
-            <a:pPr algn="ctr" indent="0" marL="0">
+            <a:pPr marL="0" indent="0" algn="ctr">
               <a:buNone/>
             </a:pPr>
             <a:r>
@@ -3415,6 +3308,13 @@
             <a:prstDash val="solid"/>
           </a:ln>
         </p:spPr>
+        <p:txBody>
+          <a:bodyPr/>
+          <a:lstStyle/>
+          <a:p>
+            <a:endParaRPr lang="en-IN"/>
+          </a:p>
+        </p:txBody>
       </p:sp>
       <p:sp>
         <p:nvSpPr>
@@ -3440,6 +3340,13 @@
             <a:prstDash val="solid"/>
           </a:ln>
         </p:spPr>
+        <p:txBody>
+          <a:bodyPr/>
+          <a:lstStyle/>
+          <a:p>
+            <a:endParaRPr lang="en-IN"/>
+          </a:p>
+        </p:txBody>
       </p:sp>
       <p:sp>
         <p:nvSpPr>
@@ -3462,7 +3369,7 @@
           <a:bodyPr wrap="square" lIns="0" tIns="0" rIns="0" bIns="0" rtlCol="0" anchor="ctr"/>
           <a:lstStyle/>
           <a:p>
-            <a:pPr algn="ctr" indent="0" marL="0">
+            <a:pPr marL="0" indent="0" algn="ctr">
               <a:buNone/>
             </a:pPr>
             <a:r>
@@ -3501,6 +3408,13 @@
             <a:prstDash val="solid"/>
           </a:ln>
         </p:spPr>
+        <p:txBody>
+          <a:bodyPr/>
+          <a:lstStyle/>
+          <a:p>
+            <a:endParaRPr lang="en-IN"/>
+          </a:p>
+        </p:txBody>
       </p:sp>
       <p:sp>
         <p:nvSpPr>
@@ -3526,6 +3440,13 @@
             <a:prstDash val="solid"/>
           </a:ln>
         </p:spPr>
+        <p:txBody>
+          <a:bodyPr/>
+          <a:lstStyle/>
+          <a:p>
+            <a:endParaRPr lang="en-IN"/>
+          </a:p>
+        </p:txBody>
       </p:sp>
       <p:sp>
         <p:nvSpPr>
@@ -3548,7 +3469,7 @@
           <a:bodyPr wrap="square" lIns="0" tIns="0" rIns="0" bIns="0" rtlCol="0" anchor="ctr"/>
           <a:lstStyle/>
           <a:p>
-            <a:pPr algn="ctr" indent="0" marL="0">
+            <a:pPr marL="0" indent="0" algn="ctr">
               <a:buNone/>
             </a:pPr>
             <a:r>
@@ -3587,6 +3508,13 @@
             <a:prstDash val="solid"/>
           </a:ln>
         </p:spPr>
+        <p:txBody>
+          <a:bodyPr/>
+          <a:lstStyle/>
+          <a:p>
+            <a:endParaRPr lang="en-IN"/>
+          </a:p>
+        </p:txBody>
       </p:sp>
       <p:sp>
         <p:nvSpPr>
@@ -3612,6 +3540,13 @@
             <a:prstDash val="solid"/>
           </a:ln>
         </p:spPr>
+        <p:txBody>
+          <a:bodyPr/>
+          <a:lstStyle/>
+          <a:p>
+            <a:endParaRPr lang="en-IN"/>
+          </a:p>
+        </p:txBody>
       </p:sp>
       <p:sp>
         <p:nvSpPr>
@@ -3634,7 +3569,7 @@
           <a:bodyPr wrap="square" lIns="0" tIns="0" rIns="0" bIns="0" rtlCol="0" anchor="ctr"/>
           <a:lstStyle/>
           <a:p>
-            <a:pPr algn="ctr" indent="0" marL="0">
+            <a:pPr marL="0" indent="0" algn="ctr">
               <a:buNone/>
             </a:pPr>
             <a:r>
@@ -3673,6 +3608,13 @@
             <a:prstDash val="solid"/>
           </a:ln>
         </p:spPr>
+        <p:txBody>
+          <a:bodyPr/>
+          <a:lstStyle/>
+          <a:p>
+            <a:endParaRPr lang="en-IN"/>
+          </a:p>
+        </p:txBody>
       </p:sp>
       <p:sp>
         <p:nvSpPr>
@@ -3695,7 +3637,7 @@
           <a:bodyPr wrap="square" lIns="0" tIns="0" rIns="0" bIns="0" rtlCol="0" anchor="ctr"/>
           <a:lstStyle/>
           <a:p>
-            <a:pPr algn="ctr" indent="0" marL="0">
+            <a:pPr marL="0" indent="0" algn="ctr">
               <a:buNone/>
             </a:pPr>
             <a:r>
@@ -3733,7 +3675,7 @@
           </a:bodyPr>
           <a:lstStyle/>
           <a:p>
-            <a:pPr algn="ctr" indent="0" marL="0">
+            <a:pPr marL="0" indent="0" algn="ctr">
               <a:buNone/>
             </a:pPr>
             <a:r>
@@ -3771,7 +3713,7 @@
           </a:bodyPr>
           <a:lstStyle/>
           <a:p>
-            <a:pPr algn="ctr" indent="0" marL="0">
+            <a:pPr marL="0" indent="0" algn="ctr">
               <a:buNone/>
             </a:pPr>
             <a:r>
@@ -3810,6 +3752,13 @@
             <a:prstDash val="solid"/>
           </a:ln>
         </p:spPr>
+        <p:txBody>
+          <a:bodyPr/>
+          <a:lstStyle/>
+          <a:p>
+            <a:endParaRPr lang="en-IN"/>
+          </a:p>
+        </p:txBody>
       </p:sp>
       <p:sp>
         <p:nvSpPr>
@@ -3832,7 +3781,7 @@
           <a:bodyPr wrap="square" lIns="0" tIns="0" rIns="0" bIns="0" rtlCol="0" anchor="ctr"/>
           <a:lstStyle/>
           <a:p>
-            <a:pPr algn="ctr" indent="0" marL="0">
+            <a:pPr marL="0" indent="0" algn="ctr">
               <a:buNone/>
             </a:pPr>
             <a:r>
@@ -3870,7 +3819,7 @@
           </a:bodyPr>
           <a:lstStyle/>
           <a:p>
-            <a:pPr algn="ctr" indent="0" marL="0">
+            <a:pPr marL="0" indent="0" algn="ctr">
               <a:buNone/>
             </a:pPr>
             <a:r>
@@ -3908,7 +3857,7 @@
           </a:bodyPr>
           <a:lstStyle/>
           <a:p>
-            <a:pPr algn="ctr" indent="0" marL="0">
+            <a:pPr marL="0" indent="0" algn="ctr">
               <a:buNone/>
             </a:pPr>
             <a:r>
@@ -3947,6 +3896,13 @@
             <a:prstDash val="solid"/>
           </a:ln>
         </p:spPr>
+        <p:txBody>
+          <a:bodyPr/>
+          <a:lstStyle/>
+          <a:p>
+            <a:endParaRPr lang="en-IN"/>
+          </a:p>
+        </p:txBody>
       </p:sp>
       <p:sp>
         <p:nvSpPr>
@@ -3969,7 +3925,7 @@
           <a:bodyPr wrap="square" lIns="0" tIns="0" rIns="0" bIns="0" rtlCol="0" anchor="ctr"/>
           <a:lstStyle/>
           <a:p>
-            <a:pPr algn="ctr" indent="0" marL="0">
+            <a:pPr marL="0" indent="0" algn="ctr">
               <a:buNone/>
             </a:pPr>
             <a:r>
@@ -4007,7 +3963,7 @@
           </a:bodyPr>
           <a:lstStyle/>
           <a:p>
-            <a:pPr algn="ctr" indent="0" marL="0">
+            <a:pPr marL="0" indent="0" algn="ctr">
               <a:buNone/>
             </a:pPr>
             <a:r>
@@ -4045,7 +4001,7 @@
           </a:bodyPr>
           <a:lstStyle/>
           <a:p>
-            <a:pPr algn="ctr" indent="0" marL="0">
+            <a:pPr marL="0" indent="0" algn="ctr">
               <a:buNone/>
             </a:pPr>
             <a:r>
@@ -4084,6 +4040,13 @@
             <a:prstDash val="solid"/>
           </a:ln>
         </p:spPr>
+        <p:txBody>
+          <a:bodyPr/>
+          <a:lstStyle/>
+          <a:p>
+            <a:endParaRPr lang="en-IN"/>
+          </a:p>
+        </p:txBody>
       </p:sp>
       <p:sp>
         <p:nvSpPr>
@@ -4106,7 +4069,7 @@
           <a:bodyPr wrap="square" lIns="0" tIns="0" rIns="0" bIns="0" rtlCol="0" anchor="ctr"/>
           <a:lstStyle/>
           <a:p>
-            <a:pPr algn="ctr" indent="0" marL="0">
+            <a:pPr marL="0" indent="0" algn="ctr">
               <a:buNone/>
             </a:pPr>
             <a:r>
@@ -4144,7 +4107,7 @@
           </a:bodyPr>
           <a:lstStyle/>
           <a:p>
-            <a:pPr algn="ctr" indent="0" marL="0">
+            <a:pPr marL="0" indent="0" algn="ctr">
               <a:buNone/>
             </a:pPr>
             <a:r>
@@ -4182,7 +4145,7 @@
           </a:bodyPr>
           <a:lstStyle/>
           <a:p>
-            <a:pPr algn="ctr" indent="0" marL="0">
+            <a:pPr marL="0" indent="0" algn="ctr">
               <a:buNone/>
             </a:pPr>
             <a:r>
@@ -4221,6 +4184,13 @@
             <a:prstDash val="solid"/>
           </a:ln>
         </p:spPr>
+        <p:txBody>
+          <a:bodyPr/>
+          <a:lstStyle/>
+          <a:p>
+            <a:endParaRPr lang="en-IN"/>
+          </a:p>
+        </p:txBody>
       </p:sp>
       <p:sp>
         <p:nvSpPr>
@@ -4243,7 +4213,7 @@
           <a:bodyPr wrap="square" lIns="0" tIns="0" rIns="0" bIns="0" rtlCol="0" anchor="ctr"/>
           <a:lstStyle/>
           <a:p>
-            <a:pPr indent="0" marL="0">
+            <a:pPr marL="0" indent="0">
               <a:buNone/>
             </a:pPr>
             <a:r>
@@ -4281,7 +4251,7 @@
           </a:bodyPr>
           <a:lstStyle/>
           <a:p>
-            <a:pPr indent="0" marL="0">
+            <a:pPr marL="0" indent="0">
               <a:buNone/>
             </a:pPr>
             <a:r>
@@ -4317,7 +4287,7 @@
           <a:bodyPr wrap="square" lIns="0" tIns="0" rIns="0" bIns="0" rtlCol="0" anchor="ctr"/>
           <a:lstStyle/>
           <a:p>
-            <a:pPr indent="0" marL="0">
+            <a:pPr marL="0" indent="0">
               <a:buNone/>
             </a:pPr>
             <a:r>
@@ -4353,7 +4323,7 @@
           <a:bodyPr wrap="square" lIns="0" tIns="0" rIns="0" bIns="0" rtlCol="0" anchor="ctr"/>
           <a:lstStyle/>
           <a:p>
-            <a:pPr indent="0" marL="0">
+            <a:pPr marL="0" indent="0">
               <a:buNone/>
             </a:pPr>
             <a:r>
@@ -4389,7 +4359,7 @@
           <a:bodyPr wrap="square" lIns="0" tIns="0" rIns="0" bIns="0" rtlCol="0" anchor="ctr"/>
           <a:lstStyle/>
           <a:p>
-            <a:pPr indent="0" marL="0">
+            <a:pPr marL="0" indent="0">
               <a:buNone/>
             </a:pPr>
             <a:r>
@@ -4425,7 +4395,7 @@
           <a:bodyPr wrap="square" lIns="0" tIns="0" rIns="0" bIns="0" rtlCol="0" anchor="ctr"/>
           <a:lstStyle/>
           <a:p>
-            <a:pPr indent="0" marL="0">
+            <a:pPr marL="0" indent="0">
               <a:buNone/>
             </a:pPr>
             <a:r>
@@ -4442,7 +4412,7 @@
       </p:sp>
       <p:sp>
         <p:nvSpPr>
-          <p:cNvPr id="25" name="Slide Number Placeholder 0"/>
+          <p:cNvPr id="47" name="Slide Number Placeholder 0"/>
           <p:cNvSpPr>
             <a:spLocks noGrp="1"/>
           </p:cNvSpPr>
@@ -4460,7 +4430,7 @@
           </a:prstGeom>
           <a:extLst>
             <a:ext uri="{C572A759-6A51-4108-AA02-DFA0A04FC94B}">
-              <ma14:wrappingTextBoxFlag xmlns:ma14="http://schemas.microsoft.com/office/mac/drawingml/2011/main" val="0"/>
+              <ma14:wrappingTextBoxFlag xmlns:ma14="http://schemas.microsoft.com/office/mac/drawingml/2011/main" xmlns="" val="0"/>
             </a:ext>
           </a:extLst>
         </p:spPr>
@@ -4481,7 +4451,7 @@
           <a:p>
             <a:pPr algn="l"/>
             <a:fld id="{F7021451-1387-4CA6-816F-3879F97B5CBC}" type="slidenum">
-              <a:rPr b="0" lang="en-US"/>
+              <a:rPr lang="en-US" b="0"/>
               <a:t>3</a:t>
             </a:fld>
             <a:endParaRPr lang="en-US"/>
@@ -4536,7 +4506,7 @@
           </a:bodyPr>
           <a:lstStyle/>
           <a:p>
-            <a:pPr indent="0" marL="0">
+            <a:pPr marL="0" indent="0">
               <a:buNone/>
             </a:pPr>
             <a:r>
@@ -4577,7 +4547,7 @@
           </a:bodyPr>
           <a:lstStyle/>
           <a:p>
-            <a:pPr indent="0" marL="0">
+            <a:pPr marL="0" indent="0">
               <a:buNone/>
             </a:pPr>
             <a:r>
@@ -4619,24 +4589,31 @@
             <a:prstDash val="solid"/>
           </a:ln>
           <a:effectLst>
-            <a:outerShdw sx="100000" sy="100000" kx="0" ky="0" algn="bl" rotWithShape="0" blurRad="19050" dist="50800" dir="2700000">
+            <a:outerShdw blurRad="19050" dist="50800" dir="2700000" algn="bl" rotWithShape="0">
               <a:srgbClr val="B8C5D6">
                 <a:alpha val="16000"/>
               </a:srgbClr>
             </a:outerShdw>
           </a:effectLst>
         </p:spPr>
+        <p:txBody>
+          <a:bodyPr/>
+          <a:lstStyle/>
+          <a:p>
+            <a:endParaRPr lang="en-IN"/>
+          </a:p>
+        </p:txBody>
       </p:sp>
       <p:pic>
         <p:nvPicPr>
-          <p:cNvPr id="5" name="Image 0" descr="/mnt/data/03_Human_Approval_Queue.png">    </p:cNvPr>
+          <p:cNvPr id="5" name="Image 0" descr="/mnt/data/03_Human_Approval_Queue.png"/>
           <p:cNvPicPr>
             <a:picLocks noChangeAspect="1"/>
           </p:cNvPicPr>
           <p:nvPr/>
         </p:nvPicPr>
         <p:blipFill>
-          <a:blip r:embed="rId1"/>
+          <a:blip r:embed="rId3"/>
           <a:stretch>
             <a:fillRect/>
           </a:stretch>
@@ -4675,6 +4652,13 @@
             <a:prstDash val="solid"/>
           </a:ln>
         </p:spPr>
+        <p:txBody>
+          <a:bodyPr/>
+          <a:lstStyle/>
+          <a:p>
+            <a:endParaRPr lang="en-IN"/>
+          </a:p>
+        </p:txBody>
       </p:sp>
       <p:sp>
         <p:nvSpPr>
@@ -4700,6 +4684,13 @@
             <a:prstDash val="solid"/>
           </a:ln>
         </p:spPr>
+        <p:txBody>
+          <a:bodyPr/>
+          <a:lstStyle/>
+          <a:p>
+            <a:endParaRPr lang="en-IN"/>
+          </a:p>
+        </p:txBody>
       </p:sp>
       <p:sp>
         <p:nvSpPr>
@@ -4722,7 +4713,7 @@
           <a:bodyPr wrap="square" lIns="0" tIns="0" rIns="0" bIns="0" rtlCol="0" anchor="ctr"/>
           <a:lstStyle/>
           <a:p>
-            <a:pPr algn="ctr" indent="0" marL="0">
+            <a:pPr marL="0" indent="0" algn="ctr">
               <a:buNone/>
             </a:pPr>
             <a:r>
@@ -4760,7 +4751,7 @@
           </a:bodyPr>
           <a:lstStyle/>
           <a:p>
-            <a:pPr indent="0" marL="0">
+            <a:pPr marL="0" indent="0">
               <a:buNone/>
             </a:pPr>
             <a:r>
@@ -4774,7 +4765,7 @@
             <a:endParaRPr lang="en-US" sz="2200" dirty="0"/>
           </a:p>
           <a:p>
-            <a:pPr indent="0" marL="0">
+            <a:pPr marL="0" indent="0">
               <a:buNone/>
             </a:pPr>
             <a:r>
@@ -4812,7 +4803,7 @@
           </a:bodyPr>
           <a:lstStyle/>
           <a:p>
-            <a:pPr indent="0" marL="0">
+            <a:pPr marL="0" indent="0">
               <a:buNone/>
             </a:pPr>
             <a:r>
@@ -4848,7 +4839,7 @@
           <a:bodyPr wrap="square" lIns="0" tIns="0" rIns="0" bIns="0" rtlCol="0" anchor="ctr"/>
           <a:lstStyle/>
           <a:p>
-            <a:pPr indent="0" marL="0">
+            <a:pPr marL="0" indent="0">
               <a:buNone/>
             </a:pPr>
             <a:r>
@@ -4884,7 +4875,7 @@
           <a:bodyPr wrap="square" lIns="0" tIns="0" rIns="0" bIns="0" rtlCol="0" anchor="ctr"/>
           <a:lstStyle/>
           <a:p>
-            <a:pPr algn="r" indent="0" marL="0">
+            <a:pPr marL="0" indent="0" algn="r">
               <a:buNone/>
             </a:pPr>
             <a:r>
@@ -4920,7 +4911,7 @@
           <a:bodyPr wrap="square" lIns="0" tIns="0" rIns="0" bIns="0" rtlCol="0" anchor="ctr"/>
           <a:lstStyle/>
           <a:p>
-            <a:pPr indent="0" marL="0">
+            <a:pPr marL="0" indent="0">
               <a:buNone/>
             </a:pPr>
             <a:r>
@@ -4956,7 +4947,7 @@
           <a:bodyPr wrap="square" lIns="0" tIns="0" rIns="0" bIns="0" rtlCol="0" anchor="ctr"/>
           <a:lstStyle/>
           <a:p>
-            <a:pPr algn="r" indent="0" marL="0">
+            <a:pPr marL="0" indent="0" algn="r">
               <a:buNone/>
             </a:pPr>
             <a:r>
@@ -4992,7 +4983,7 @@
           <a:bodyPr wrap="square" lIns="0" tIns="0" rIns="0" bIns="0" rtlCol="0" anchor="ctr"/>
           <a:lstStyle/>
           <a:p>
-            <a:pPr indent="0" marL="0">
+            <a:pPr marL="0" indent="0">
               <a:buNone/>
             </a:pPr>
             <a:r>
@@ -5028,7 +5019,7 @@
           <a:bodyPr wrap="square" lIns="0" tIns="0" rIns="0" bIns="0" rtlCol="0" anchor="ctr"/>
           <a:lstStyle/>
           <a:p>
-            <a:pPr algn="r" indent="0" marL="0">
+            <a:pPr marL="0" indent="0" algn="r">
               <a:buNone/>
             </a:pPr>
             <a:r>
@@ -5064,7 +5055,7 @@
           <a:bodyPr wrap="square" lIns="0" tIns="0" rIns="0" bIns="0" rtlCol="0" anchor="ctr"/>
           <a:lstStyle/>
           <a:p>
-            <a:pPr indent="0" marL="0">
+            <a:pPr marL="0" indent="0">
               <a:buNone/>
             </a:pPr>
             <a:r>
@@ -5100,7 +5091,7 @@
           <a:bodyPr wrap="square" lIns="0" tIns="0" rIns="0" bIns="0" rtlCol="0" anchor="ctr"/>
           <a:lstStyle/>
           <a:p>
-            <a:pPr algn="r" indent="0" marL="0">
+            <a:pPr marL="0" indent="0" algn="r">
               <a:buNone/>
             </a:pPr>
             <a:r>
@@ -5135,7 +5126,7 @@
           </a:prstGeom>
           <a:extLst>
             <a:ext uri="{C572A759-6A51-4108-AA02-DFA0A04FC94B}">
-              <ma14:wrappingTextBoxFlag xmlns:ma14="http://schemas.microsoft.com/office/mac/drawingml/2011/main" val="0"/>
+              <ma14:wrappingTextBoxFlag xmlns:ma14="http://schemas.microsoft.com/office/mac/drawingml/2011/main" xmlns="" val="0"/>
             </a:ext>
           </a:extLst>
         </p:spPr>
@@ -5156,7 +5147,7 @@
           <a:p>
             <a:pPr algn="l"/>
             <a:fld id="{F7021451-1387-4CA6-816F-3879F97B5CBC}" type="slidenum">
-              <a:rPr b="0" lang="en-US"/>
+              <a:rPr lang="en-US" b="0"/>
               <a:t>4</a:t>
             </a:fld>
             <a:endParaRPr lang="en-US"/>
@@ -5209,7 +5200,7 @@
           <a:bodyPr wrap="square" lIns="0" tIns="0" rIns="0" bIns="0" rtlCol="0" anchor="ctr"/>
           <a:lstStyle/>
           <a:p>
-            <a:pPr indent="0" marL="0">
+            <a:pPr marL="0" indent="0">
               <a:buNone/>
             </a:pPr>
             <a:r>
@@ -5245,7 +5236,7 @@
           <a:bodyPr wrap="square" lIns="0" tIns="0" rIns="0" bIns="0" rtlCol="0" anchor="ctr"/>
           <a:lstStyle/>
           <a:p>
-            <a:pPr indent="0" marL="0">
+            <a:pPr marL="0" indent="0">
               <a:buNone/>
             </a:pPr>
             <a:r>
@@ -5284,6 +5275,13 @@
             <a:prstDash val="solid"/>
           </a:ln>
         </p:spPr>
+        <p:txBody>
+          <a:bodyPr/>
+          <a:lstStyle/>
+          <a:p>
+            <a:endParaRPr lang="en-IN"/>
+          </a:p>
+        </p:txBody>
       </p:sp>
       <p:sp>
         <p:nvSpPr>
@@ -5306,7 +5304,7 @@
           <a:bodyPr wrap="square" lIns="0" tIns="0" rIns="0" bIns="0" rtlCol="0" anchor="ctr"/>
           <a:lstStyle/>
           <a:p>
-            <a:pPr algn="ctr" indent="0" marL="0">
+            <a:pPr marL="0" indent="0" algn="ctr">
               <a:buNone/>
             </a:pPr>
             <a:r>
@@ -5342,7 +5340,7 @@
           <a:bodyPr wrap="square" lIns="0" tIns="0" rIns="0" bIns="0" rtlCol="0" anchor="ctr"/>
           <a:lstStyle/>
           <a:p>
-            <a:pPr indent="0" marL="0">
+            <a:pPr marL="0" indent="0">
               <a:buNone/>
             </a:pPr>
             <a:r>
@@ -5380,7 +5378,7 @@
           </a:bodyPr>
           <a:lstStyle/>
           <a:p>
-            <a:pPr indent="0" marL="0">
+            <a:pPr marL="0" indent="0">
               <a:buNone/>
             </a:pPr>
             <a:r>
@@ -5419,6 +5417,13 @@
             <a:prstDash val="solid"/>
           </a:ln>
         </p:spPr>
+        <p:txBody>
+          <a:bodyPr/>
+          <a:lstStyle/>
+          <a:p>
+            <a:endParaRPr lang="en-IN"/>
+          </a:p>
+        </p:txBody>
       </p:sp>
       <p:sp>
         <p:nvSpPr>
@@ -5441,7 +5446,7 @@
           <a:bodyPr wrap="square" lIns="0" tIns="0" rIns="0" bIns="0" rtlCol="0" anchor="ctr"/>
           <a:lstStyle/>
           <a:p>
-            <a:pPr algn="ctr" indent="0" marL="0">
+            <a:pPr marL="0" indent="0" algn="ctr">
               <a:buNone/>
             </a:pPr>
             <a:r>
@@ -5477,7 +5482,7 @@
           <a:bodyPr wrap="square" lIns="0" tIns="0" rIns="0" bIns="0" rtlCol="0" anchor="ctr"/>
           <a:lstStyle/>
           <a:p>
-            <a:pPr indent="0" marL="0">
+            <a:pPr marL="0" indent="0">
               <a:buNone/>
             </a:pPr>
             <a:r>
@@ -5515,7 +5520,7 @@
           </a:bodyPr>
           <a:lstStyle/>
           <a:p>
-            <a:pPr indent="0" marL="0">
+            <a:pPr marL="0" indent="0">
               <a:buNone/>
             </a:pPr>
             <a:r>
@@ -5554,6 +5559,13 @@
             <a:prstDash val="solid"/>
           </a:ln>
         </p:spPr>
+        <p:txBody>
+          <a:bodyPr/>
+          <a:lstStyle/>
+          <a:p>
+            <a:endParaRPr lang="en-IN"/>
+          </a:p>
+        </p:txBody>
       </p:sp>
       <p:sp>
         <p:nvSpPr>
@@ -5576,7 +5588,7 @@
           <a:bodyPr wrap="square" lIns="0" tIns="0" rIns="0" bIns="0" rtlCol="0" anchor="ctr"/>
           <a:lstStyle/>
           <a:p>
-            <a:pPr algn="ctr" indent="0" marL="0">
+            <a:pPr marL="0" indent="0" algn="ctr">
               <a:buNone/>
             </a:pPr>
             <a:r>
@@ -5612,7 +5624,7 @@
           <a:bodyPr wrap="square" lIns="0" tIns="0" rIns="0" bIns="0" rtlCol="0" anchor="ctr"/>
           <a:lstStyle/>
           <a:p>
-            <a:pPr indent="0" marL="0">
+            <a:pPr marL="0" indent="0">
               <a:buNone/>
             </a:pPr>
             <a:r>
@@ -5650,7 +5662,7 @@
           </a:bodyPr>
           <a:lstStyle/>
           <a:p>
-            <a:pPr indent="0" marL="0">
+            <a:pPr marL="0" indent="0">
               <a:buNone/>
             </a:pPr>
             <a:r>
@@ -5689,6 +5701,13 @@
             <a:prstDash val="solid"/>
           </a:ln>
         </p:spPr>
+        <p:txBody>
+          <a:bodyPr/>
+          <a:lstStyle/>
+          <a:p>
+            <a:endParaRPr lang="en-IN"/>
+          </a:p>
+        </p:txBody>
       </p:sp>
       <p:sp>
         <p:nvSpPr>
@@ -5711,7 +5730,7 @@
           <a:bodyPr wrap="square" lIns="0" tIns="0" rIns="0" bIns="0" rtlCol="0" anchor="ctr"/>
           <a:lstStyle/>
           <a:p>
-            <a:pPr algn="ctr" indent="0" marL="0">
+            <a:pPr marL="0" indent="0" algn="ctr">
               <a:buNone/>
             </a:pPr>
             <a:r>
@@ -5747,7 +5766,7 @@
           <a:bodyPr wrap="square" lIns="0" tIns="0" rIns="0" bIns="0" rtlCol="0" anchor="ctr"/>
           <a:lstStyle/>
           <a:p>
-            <a:pPr indent="0" marL="0">
+            <a:pPr marL="0" indent="0">
               <a:buNone/>
             </a:pPr>
             <a:r>
@@ -5785,7 +5804,7 @@
           </a:bodyPr>
           <a:lstStyle/>
           <a:p>
-            <a:pPr indent="0" marL="0">
+            <a:pPr marL="0" indent="0">
               <a:buNone/>
             </a:pPr>
             <a:r>
@@ -5824,17 +5843,24 @@
             <a:prstDash val="solid"/>
           </a:ln>
         </p:spPr>
+        <p:txBody>
+          <a:bodyPr/>
+          <a:lstStyle/>
+          <a:p>
+            <a:endParaRPr lang="en-IN"/>
+          </a:p>
+        </p:txBody>
       </p:sp>
       <p:pic>
         <p:nvPicPr>
-          <p:cNvPr id="21" name="Image 0" descr="/mnt/data/01_ClauseRunner_Dashboard.png">    </p:cNvPr>
+          <p:cNvPr id="21" name="Image 0" descr="/mnt/data/01_ClauseRunner_Dashboard.png"/>
           <p:cNvPicPr>
             <a:picLocks noChangeAspect="1"/>
           </p:cNvPicPr>
           <p:nvPr/>
         </p:nvPicPr>
         <p:blipFill>
-          <a:blip r:embed="rId1"/>
+          <a:blip r:embed="rId3"/>
           <a:stretch>
             <a:fillRect/>
           </a:stretch>
@@ -5869,7 +5895,7 @@
           </a:prstGeom>
           <a:extLst>
             <a:ext uri="{C572A759-6A51-4108-AA02-DFA0A04FC94B}">
-              <ma14:wrappingTextBoxFlag xmlns:ma14="http://schemas.microsoft.com/office/mac/drawingml/2011/main" val="0"/>
+              <ma14:wrappingTextBoxFlag xmlns:ma14="http://schemas.microsoft.com/office/mac/drawingml/2011/main" xmlns="" val="0"/>
             </a:ext>
           </a:extLst>
         </p:spPr>
@@ -5890,7 +5916,7 @@
           <a:p>
             <a:pPr algn="l"/>
             <a:fld id="{F7021451-1387-4CA6-816F-3879F97B5CBC}" type="slidenum">
-              <a:rPr b="0" lang="en-US"/>
+              <a:rPr lang="en-US" b="0"/>
               <a:t>5</a:t>
             </a:fld>
             <a:endParaRPr lang="en-US"/>
@@ -5945,7 +5971,7 @@
           </a:bodyPr>
           <a:lstStyle/>
           <a:p>
-            <a:pPr indent="0" marL="0">
+            <a:pPr marL="0" indent="0">
               <a:buNone/>
             </a:pPr>
             <a:r>
@@ -5986,7 +6012,7 @@
           </a:bodyPr>
           <a:lstStyle/>
           <a:p>
-            <a:pPr indent="0" marL="0">
+            <a:pPr marL="0" indent="0">
               <a:buNone/>
             </a:pPr>
             <a:r>
@@ -6028,24 +6054,31 @@
             <a:prstDash val="solid"/>
           </a:ln>
           <a:effectLst>
-            <a:outerShdw sx="100000" sy="100000" kx="0" ky="0" algn="bl" rotWithShape="0" blurRad="15240" dist="50800" dir="2700000">
+            <a:outerShdw blurRad="15240" dist="50800" dir="2700000" algn="bl" rotWithShape="0">
               <a:srgbClr val="B8C5D6">
                 <a:alpha val="14000"/>
               </a:srgbClr>
             </a:outerShdw>
           </a:effectLst>
         </p:spPr>
+        <p:txBody>
+          <a:bodyPr/>
+          <a:lstStyle/>
+          <a:p>
+            <a:endParaRPr lang="en-IN"/>
+          </a:p>
+        </p:txBody>
       </p:sp>
       <p:pic>
         <p:nvPicPr>
-          <p:cNvPr id="5" name="Image 0" descr="/mnt/data/clauserunner_aws_architecture_diagram.png">    </p:cNvPr>
+          <p:cNvPr id="5" name="Image 0" descr="/mnt/data/clauserunner_aws_architecture_diagram.png"/>
           <p:cNvPicPr>
             <a:picLocks noChangeAspect="1"/>
           </p:cNvPicPr>
           <p:nvPr/>
         </p:nvPicPr>
         <p:blipFill>
-          <a:blip r:embed="rId1"/>
+          <a:blip r:embed="rId3"/>
           <a:stretch>
             <a:fillRect/>
           </a:stretch>
@@ -6080,7 +6113,7 @@
           </a:prstGeom>
           <a:extLst>
             <a:ext uri="{C572A759-6A51-4108-AA02-DFA0A04FC94B}">
-              <ma14:wrappingTextBoxFlag xmlns:ma14="http://schemas.microsoft.com/office/mac/drawingml/2011/main" val="0"/>
+              <ma14:wrappingTextBoxFlag xmlns:ma14="http://schemas.microsoft.com/office/mac/drawingml/2011/main" xmlns="" val="0"/>
             </a:ext>
           </a:extLst>
         </p:spPr>
@@ -6101,7 +6134,7 @@
           <a:p>
             <a:pPr algn="l"/>
             <a:fld id="{F7021451-1387-4CA6-816F-3879F97B5CBC}" type="slidenum">
-              <a:rPr b="0" lang="en-US"/>
+              <a:rPr lang="en-US" b="0"/>
               <a:t>6</a:t>
             </a:fld>
             <a:endParaRPr lang="en-US"/>
@@ -6157,6 +6190,13 @@
             <a:prstDash val="solid"/>
           </a:ln>
         </p:spPr>
+        <p:txBody>
+          <a:bodyPr/>
+          <a:lstStyle/>
+          <a:p>
+            <a:endParaRPr lang="en-IN"/>
+          </a:p>
+        </p:txBody>
       </p:sp>
       <p:sp>
         <p:nvSpPr>
@@ -6179,7 +6219,7 @@
           <a:bodyPr wrap="square" lIns="0" tIns="0" rIns="0" bIns="0" rtlCol="0" anchor="ctr"/>
           <a:lstStyle/>
           <a:p>
-            <a:pPr algn="ctr" indent="0" marL="0">
+            <a:pPr marL="0" indent="0" algn="ctr">
               <a:buNone/>
             </a:pPr>
             <a:r>
@@ -6217,7 +6257,7 @@
           </a:bodyPr>
           <a:lstStyle/>
           <a:p>
-            <a:pPr indent="0" marL="0">
+            <a:pPr marL="0" indent="0">
               <a:buNone/>
             </a:pPr>
             <a:r>
@@ -6253,7 +6293,7 @@
           <a:bodyPr wrap="square" lIns="0" tIns="0" rIns="0" bIns="0" rtlCol="0" anchor="ctr"/>
           <a:lstStyle/>
           <a:p>
-            <a:pPr indent="0" marL="0">
+            <a:pPr marL="0" indent="0">
               <a:buNone/>
             </a:pPr>
             <a:r>
@@ -6291,7 +6331,7 @@
           </a:bodyPr>
           <a:lstStyle/>
           <a:p>
-            <a:pPr indent="0" marL="0">
+            <a:pPr marL="0" indent="0">
               <a:buNone/>
             </a:pPr>
             <a:r>
@@ -6330,6 +6370,13 @@
             <a:prstDash val="solid"/>
           </a:ln>
         </p:spPr>
+        <p:txBody>
+          <a:bodyPr/>
+          <a:lstStyle/>
+          <a:p>
+            <a:endParaRPr lang="en-IN"/>
+          </a:p>
+        </p:txBody>
       </p:sp>
       <p:sp>
         <p:nvSpPr>
@@ -6352,7 +6399,7 @@
           <a:bodyPr wrap="square" lIns="0" tIns="0" rIns="0" bIns="0" rtlCol="0" anchor="ctr"/>
           <a:lstStyle/>
           <a:p>
-            <a:pPr indent="0" marL="0">
+            <a:pPr marL="0" indent="0">
               <a:buNone/>
             </a:pPr>
             <a:r>
@@ -6390,7 +6437,7 @@
           </a:bodyPr>
           <a:lstStyle/>
           <a:p>
-            <a:pPr indent="0" marL="0">
+            <a:pPr marL="0" indent="0">
               <a:buNone/>
             </a:pPr>
             <a:r>
@@ -6429,6 +6476,13 @@
             <a:prstDash val="solid"/>
           </a:ln>
         </p:spPr>
+        <p:txBody>
+          <a:bodyPr/>
+          <a:lstStyle/>
+          <a:p>
+            <a:endParaRPr lang="en-IN"/>
+          </a:p>
+        </p:txBody>
       </p:sp>
       <p:sp>
         <p:nvSpPr>
@@ -6451,7 +6505,7 @@
           <a:bodyPr wrap="square" lIns="0" tIns="0" rIns="0" bIns="0" rtlCol="0" anchor="ctr"/>
           <a:lstStyle/>
           <a:p>
-            <a:pPr indent="0" marL="0">
+            <a:pPr marL="0" indent="0">
               <a:buNone/>
             </a:pPr>
             <a:r>
@@ -6489,7 +6543,7 @@
           </a:bodyPr>
           <a:lstStyle/>
           <a:p>
-            <a:pPr indent="0" marL="0">
+            <a:pPr marL="0" indent="0">
               <a:buNone/>
             </a:pPr>
             <a:r>
@@ -6528,6 +6582,13 @@
             <a:prstDash val="solid"/>
           </a:ln>
         </p:spPr>
+        <p:txBody>
+          <a:bodyPr/>
+          <a:lstStyle/>
+          <a:p>
+            <a:endParaRPr lang="en-IN"/>
+          </a:p>
+        </p:txBody>
       </p:sp>
       <p:sp>
         <p:nvSpPr>
@@ -6550,7 +6611,7 @@
           <a:bodyPr wrap="square" lIns="0" tIns="0" rIns="0" bIns="0" rtlCol="0" anchor="ctr"/>
           <a:lstStyle/>
           <a:p>
-            <a:pPr indent="0" marL="0">
+            <a:pPr marL="0" indent="0">
               <a:buNone/>
             </a:pPr>
             <a:r>
@@ -6588,7 +6649,7 @@
           </a:bodyPr>
           <a:lstStyle/>
           <a:p>
-            <a:pPr indent="0" marL="0">
+            <a:pPr marL="0" indent="0">
               <a:buNone/>
             </a:pPr>
             <a:r>
@@ -6611,7 +6672,7 @@
         </p:nvSpPr>
         <p:spPr>
           <a:xfrm>
-            <a:off x="676656" y="5961888"/>
+            <a:off x="658368" y="5961888"/>
             <a:ext cx="7040880" cy="219456"/>
           </a:xfrm>
           <a:prstGeom prst="rect">
@@ -6624,7 +6685,7 @@
           <a:bodyPr wrap="square" lIns="0" tIns="0" rIns="0" bIns="0" rtlCol="0" anchor="ctr"/>
           <a:lstStyle/>
           <a:p>
-            <a:pPr indent="0" marL="0">
+            <a:pPr marL="0" indent="0">
               <a:buNone/>
             </a:pPr>
             <a:r>
@@ -6659,7 +6720,7 @@
           </a:prstGeom>
           <a:extLst>
             <a:ext uri="{C572A759-6A51-4108-AA02-DFA0A04FC94B}">
-              <ma14:wrappingTextBoxFlag xmlns:ma14="http://schemas.microsoft.com/office/mac/drawingml/2011/main" val="0"/>
+              <ma14:wrappingTextBoxFlag xmlns:ma14="http://schemas.microsoft.com/office/mac/drawingml/2011/main" xmlns="" val="0"/>
             </a:ext>
           </a:extLst>
         </p:spPr>
@@ -6680,7 +6741,7 @@
           <a:p>
             <a:pPr algn="l"/>
             <a:fld id="{F7021451-1387-4CA6-816F-3879F97B5CBC}" type="slidenum">
-              <a:rPr b="0" lang="en-US"/>
+              <a:rPr lang="en-US" b="0"/>
               <a:t>7</a:t>
             </a:fld>
             <a:endParaRPr lang="en-US"/>
@@ -6988,4 +7049,319 @@
     </a:ext>
   </a:extLst>
 </a:theme>
+</file>
+
+<file path=ppt/theme/theme2.xml><?xml version="1.0" encoding="utf-8"?>
+<a:theme xmlns:a="http://schemas.openxmlformats.org/drawingml/2006/main" name="Office Theme">
+  <a:themeElements>
+    <a:clrScheme name="Office">
+      <a:dk1>
+        <a:sysClr val="windowText" lastClr="000000"/>
+      </a:dk1>
+      <a:lt1>
+        <a:sysClr val="window" lastClr="FFFFFF"/>
+      </a:lt1>
+      <a:dk2>
+        <a:srgbClr val="0E2841"/>
+      </a:dk2>
+      <a:lt2>
+        <a:srgbClr val="E8E8E8"/>
+      </a:lt2>
+      <a:accent1>
+        <a:srgbClr val="156082"/>
+      </a:accent1>
+      <a:accent2>
+        <a:srgbClr val="E97132"/>
+      </a:accent2>
+      <a:accent3>
+        <a:srgbClr val="196B24"/>
+      </a:accent3>
+      <a:accent4>
+        <a:srgbClr val="0F9ED5"/>
+      </a:accent4>
+      <a:accent5>
+        <a:srgbClr val="A02B93"/>
+      </a:accent5>
+      <a:accent6>
+        <a:srgbClr val="4EA72E"/>
+      </a:accent6>
+      <a:hlink>
+        <a:srgbClr val="467886"/>
+      </a:hlink>
+      <a:folHlink>
+        <a:srgbClr val="96607D"/>
+      </a:folHlink>
+    </a:clrScheme>
+    <a:fontScheme name="Office">
+      <a:majorFont>
+        <a:latin typeface="Aptos Display" panose="02110004020202020204"/>
+        <a:ea typeface=""/>
+        <a:cs typeface=""/>
+        <a:font script="Jpan" typeface="游ゴシック Light"/>
+        <a:font script="Hang" typeface="맑은 고딕"/>
+        <a:font script="Hans" typeface="等线 Light"/>
+        <a:font script="Hant" typeface="新細明體"/>
+        <a:font script="Arab" typeface="Times New Roman"/>
+        <a:font script="Hebr" typeface="Times New Roman"/>
+        <a:font script="Thai" typeface="Angsana New"/>
+        <a:font script="Ethi" typeface="Nyala"/>
+        <a:font script="Beng" typeface="Vrinda"/>
+        <a:font script="Gujr" typeface="Shruti"/>
+        <a:font script="Khmr" typeface="MoolBoran"/>
+        <a:font script="Knda" typeface="Tunga"/>
+        <a:font script="Guru" typeface="Raavi"/>
+        <a:font script="Cans" typeface="Euphemia"/>
+        <a:font script="Cher" typeface="Plantagenet Cherokee"/>
+        <a:font script="Yiii" typeface="Microsoft Yi Baiti"/>
+        <a:font script="Tibt" typeface="Microsoft Himalaya"/>
+        <a:font script="Thaa" typeface="MV Boli"/>
+        <a:font script="Deva" typeface="Mangal"/>
+        <a:font script="Telu" typeface="Gautami"/>
+        <a:font script="Taml" typeface="Latha"/>
+        <a:font script="Syrc" typeface="Estrangelo Edessa"/>
+        <a:font script="Orya" typeface="Kalinga"/>
+        <a:font script="Mlym" typeface="Kartika"/>
+        <a:font script="Laoo" typeface="DokChampa"/>
+        <a:font script="Sinh" typeface="Iskoola Pota"/>
+        <a:font script="Mong" typeface="Mongolian Baiti"/>
+        <a:font script="Viet" typeface="Times New Roman"/>
+        <a:font script="Uigh" typeface="Microsoft Uighur"/>
+        <a:font script="Geor" typeface="Sylfaen"/>
+        <a:font script="Armn" typeface="Arial"/>
+        <a:font script="Bugi" typeface="Leelawadee UI"/>
+        <a:font script="Bopo" typeface="Microsoft JhengHei"/>
+        <a:font script="Java" typeface="Javanese Text"/>
+        <a:font script="Lisu" typeface="Segoe UI"/>
+        <a:font script="Mymr" typeface="Myanmar Text"/>
+        <a:font script="Nkoo" typeface="Ebrima"/>
+        <a:font script="Olck" typeface="Nirmala UI"/>
+        <a:font script="Osma" typeface="Ebrima"/>
+        <a:font script="Phag" typeface="Phagspa"/>
+        <a:font script="Syrn" typeface="Estrangelo Edessa"/>
+        <a:font script="Syrj" typeface="Estrangelo Edessa"/>
+        <a:font script="Syre" typeface="Estrangelo Edessa"/>
+        <a:font script="Sora" typeface="Nirmala UI"/>
+        <a:font script="Tale" typeface="Microsoft Tai Le"/>
+        <a:font script="Talu" typeface="Microsoft New Tai Lue"/>
+        <a:font script="Tfng" typeface="Ebrima"/>
+      </a:majorFont>
+      <a:minorFont>
+        <a:latin typeface="Aptos" panose="02110004020202020204"/>
+        <a:ea typeface=""/>
+        <a:cs typeface=""/>
+        <a:font script="Jpan" typeface="游ゴシック"/>
+        <a:font script="Hang" typeface="맑은 고딕"/>
+        <a:font script="Hans" typeface="等线"/>
+        <a:font script="Hant" typeface="新細明體"/>
+        <a:font script="Arab" typeface="Arial"/>
+        <a:font script="Hebr" typeface="Arial"/>
+        <a:font script="Thai" typeface="Cordia New"/>
+        <a:font script="Ethi" typeface="Nyala"/>
+        <a:font script="Beng" typeface="Vrinda"/>
+        <a:font script="Gujr" typeface="Shruti"/>
+        <a:font script="Khmr" typeface="DaunPenh"/>
+        <a:font script="Knda" typeface="Tunga"/>
+        <a:font script="Guru" typeface="Raavi"/>
+        <a:font script="Cans" typeface="Euphemia"/>
+        <a:font script="Cher" typeface="Plantagenet Cherokee"/>
+        <a:font script="Yiii" typeface="Microsoft Yi Baiti"/>
+        <a:font script="Tibt" typeface="Microsoft Himalaya"/>
+        <a:font script="Thaa" typeface="MV Boli"/>
+        <a:font script="Deva" typeface="Mangal"/>
+        <a:font script="Telu" typeface="Gautami"/>
+        <a:font script="Taml" typeface="Latha"/>
+        <a:font script="Syrc" typeface="Estrangelo Edessa"/>
+        <a:font script="Orya" typeface="Kalinga"/>
+        <a:font script="Mlym" typeface="Kartika"/>
+        <a:font script="Laoo" typeface="DokChampa"/>
+        <a:font script="Sinh" typeface="Iskoola Pota"/>
+        <a:font script="Mong" typeface="Mongolian Baiti"/>
+        <a:font script="Viet" typeface="Arial"/>
+        <a:font script="Uigh" typeface="Microsoft Uighur"/>
+        <a:font script="Geor" typeface="Sylfaen"/>
+        <a:font script="Armn" typeface="Arial"/>
+        <a:font script="Bugi" typeface="Leelawadee UI"/>
+        <a:font script="Bopo" typeface="Microsoft JhengHei"/>
+        <a:font script="Java" typeface="Javanese Text"/>
+        <a:font script="Lisu" typeface="Segoe UI"/>
+        <a:font script="Mymr" typeface="Myanmar Text"/>
+        <a:font script="Nkoo" typeface="Ebrima"/>
+        <a:font script="Olck" typeface="Nirmala UI"/>
+        <a:font script="Osma" typeface="Ebrima"/>
+        <a:font script="Phag" typeface="Phagspa"/>
+        <a:font script="Syrn" typeface="Estrangelo Edessa"/>
+        <a:font script="Syrj" typeface="Estrangelo Edessa"/>
+        <a:font script="Syre" typeface="Estrangelo Edessa"/>
+        <a:font script="Sora" typeface="Nirmala UI"/>
+        <a:font script="Tale" typeface="Microsoft Tai Le"/>
+        <a:font script="Talu" typeface="Microsoft New Tai Lue"/>
+        <a:font script="Tfng" typeface="Ebrima"/>
+      </a:minorFont>
+    </a:fontScheme>
+    <a:fmtScheme name="Office">
+      <a:fillStyleLst>
+        <a:solidFill>
+          <a:schemeClr val="phClr"/>
+        </a:solidFill>
+        <a:gradFill rotWithShape="1">
+          <a:gsLst>
+            <a:gs pos="0">
+              <a:schemeClr val="phClr">
+                <a:lumMod val="110000"/>
+                <a:satMod val="105000"/>
+                <a:tint val="67000"/>
+              </a:schemeClr>
+            </a:gs>
+            <a:gs pos="50000">
+              <a:schemeClr val="phClr">
+                <a:lumMod val="105000"/>
+                <a:satMod val="103000"/>
+                <a:tint val="73000"/>
+              </a:schemeClr>
+            </a:gs>
+            <a:gs pos="100000">
+              <a:schemeClr val="phClr">
+                <a:lumMod val="105000"/>
+                <a:satMod val="109000"/>
+                <a:tint val="81000"/>
+              </a:schemeClr>
+            </a:gs>
+          </a:gsLst>
+          <a:lin ang="5400000" scaled="0"/>
+        </a:gradFill>
+        <a:gradFill rotWithShape="1">
+          <a:gsLst>
+            <a:gs pos="0">
+              <a:schemeClr val="phClr">
+                <a:satMod val="103000"/>
+                <a:lumMod val="102000"/>
+                <a:tint val="94000"/>
+              </a:schemeClr>
+            </a:gs>
+            <a:gs pos="50000">
+              <a:schemeClr val="phClr">
+                <a:satMod val="110000"/>
+                <a:lumMod val="100000"/>
+                <a:shade val="100000"/>
+              </a:schemeClr>
+            </a:gs>
+            <a:gs pos="100000">
+              <a:schemeClr val="phClr">
+                <a:lumMod val="99000"/>
+                <a:satMod val="120000"/>
+                <a:shade val="78000"/>
+              </a:schemeClr>
+            </a:gs>
+          </a:gsLst>
+          <a:lin ang="5400000" scaled="0"/>
+        </a:gradFill>
+      </a:fillStyleLst>
+      <a:lnStyleLst>
+        <a:ln w="12700" cap="flat" cmpd="sng" algn="ctr">
+          <a:solidFill>
+            <a:schemeClr val="phClr"/>
+          </a:solidFill>
+          <a:prstDash val="solid"/>
+          <a:miter lim="800000"/>
+        </a:ln>
+        <a:ln w="19050" cap="flat" cmpd="sng" algn="ctr">
+          <a:solidFill>
+            <a:schemeClr val="phClr"/>
+          </a:solidFill>
+          <a:prstDash val="solid"/>
+          <a:miter lim="800000"/>
+        </a:ln>
+        <a:ln w="25400" cap="flat" cmpd="sng" algn="ctr">
+          <a:solidFill>
+            <a:schemeClr val="phClr"/>
+          </a:solidFill>
+          <a:prstDash val="solid"/>
+          <a:miter lim="800000"/>
+        </a:ln>
+      </a:lnStyleLst>
+      <a:effectStyleLst>
+        <a:effectStyle>
+          <a:effectLst/>
+        </a:effectStyle>
+        <a:effectStyle>
+          <a:effectLst/>
+        </a:effectStyle>
+        <a:effectStyle>
+          <a:effectLst>
+            <a:outerShdw blurRad="57150" dist="19050" dir="5400000" algn="ctr" rotWithShape="0">
+              <a:srgbClr val="000000">
+                <a:alpha val="63000"/>
+              </a:srgbClr>
+            </a:outerShdw>
+          </a:effectLst>
+        </a:effectStyle>
+      </a:effectStyleLst>
+      <a:bgFillStyleLst>
+        <a:solidFill>
+          <a:schemeClr val="phClr"/>
+        </a:solidFill>
+        <a:solidFill>
+          <a:schemeClr val="phClr">
+            <a:tint val="95000"/>
+            <a:satMod val="170000"/>
+          </a:schemeClr>
+        </a:solidFill>
+        <a:gradFill rotWithShape="1">
+          <a:gsLst>
+            <a:gs pos="0">
+              <a:schemeClr val="phClr">
+                <a:tint val="93000"/>
+                <a:satMod val="150000"/>
+                <a:shade val="98000"/>
+                <a:lumMod val="102000"/>
+              </a:schemeClr>
+            </a:gs>
+            <a:gs pos="50000">
+              <a:schemeClr val="phClr">
+                <a:tint val="98000"/>
+                <a:satMod val="130000"/>
+                <a:shade val="90000"/>
+                <a:lumMod val="103000"/>
+              </a:schemeClr>
+            </a:gs>
+            <a:gs pos="100000">
+              <a:schemeClr val="phClr">
+                <a:shade val="63000"/>
+                <a:satMod val="120000"/>
+              </a:schemeClr>
+            </a:gs>
+          </a:gsLst>
+          <a:lin ang="5400000" scaled="0"/>
+        </a:gradFill>
+      </a:bgFillStyleLst>
+    </a:fmtScheme>
+  </a:themeElements>
+  <a:objectDefaults>
+    <a:lnDef>
+      <a:spPr/>
+      <a:bodyPr/>
+      <a:lstStyle/>
+      <a:style>
+        <a:lnRef idx="2">
+          <a:schemeClr val="accent1"/>
+        </a:lnRef>
+        <a:fillRef idx="0">
+          <a:schemeClr val="accent1"/>
+        </a:fillRef>
+        <a:effectRef idx="1">
+          <a:schemeClr val="accent1"/>
+        </a:effectRef>
+        <a:fontRef idx="minor">
+          <a:schemeClr val="tx1"/>
+        </a:fontRef>
+      </a:style>
+    </a:lnDef>
+  </a:objectDefaults>
+  <a:extraClrSchemeLst/>
+  <a:extLst>
+    <a:ext uri="{05A4C25C-085E-4340-85A3-A5531E510DB2}">
+      <thm15:themeFamily xmlns:thm15="http://schemas.microsoft.com/office/thememl/2012/main" name="Office Theme" id="{2E142A2C-CD16-42D6-873A-C26D2A0506FA}" vid="{1BDDFF52-6CD6-40A5-AB3C-68EB2F1E4D0A}"/>
+    </a:ext>
+  </a:extLst>
+</a:theme>
 </file>
</xml_diff>